<commit_message>
fix(presentation): use palette color for steerco decision card borders
</commit_message>
<xml_diff>
--- a/packages/desktop/resources/presentation-templates/monthly-steerco.pptx
+++ b/packages/desktop/resources/presentation-templates/monthly-steerco.pptx
@@ -5,14 +5,14 @@
     <p:sldMasterId xmlns:r="http://schemas.openxmlformats.org/officeDocument/2006/relationships" id="2147483648" r:id="rId1"/>
   </p:sldMasterIdLst>
   <p:sldIdLst>
-    <p:sldId id="256" r:id="Rb55817c18c6e4aa6"/>
-    <p:sldId id="257" r:id="R601536569e6a4944"/>
-    <p:sldId id="258" r:id="R6942d84cb7ef449b"/>
-    <p:sldId id="259" r:id="Rc68da2aec780428f"/>
-    <p:sldId id="260" r:id="R4bed21e8e26542f3"/>
-    <p:sldId id="261" r:id="R80fce563d5864557"/>
-    <p:sldId id="262" r:id="R5f8793e38f7a42b0"/>
-    <p:sldId id="263" r:id="Ra7ce3421bb134023"/>
+    <p:sldId id="256" r:id="R2b1746356e9d4c01"/>
+    <p:sldId id="257" r:id="R0705b586e35045f9"/>
+    <p:sldId id="258" r:id="R089f382eb6504660"/>
+    <p:sldId id="259" r:id="R5a6f9fd8ced44a4f"/>
+    <p:sldId id="260" r:id="Rd87f9c5b79f144f8"/>
+    <p:sldId id="261" r:id="R042ee6010fea45ff"/>
+    <p:sldId id="262" r:id="Ra24a877974074604"/>
+    <p:sldId id="263" r:id="R67d9bf13e3b4484d"/>
   </p:sldIdLst>
   <p:sldSz cx="12192000" cy="6858000"/>
   <p:notesSz cx="6858000" cy="9144000"/>
@@ -3031,7 +3031,7 @@
           </a:solidFill>
           <a:ln xmlns:a="http://schemas.openxmlformats.org/drawingml/2006/main">
             <a:solidFill>
-              <a:srgbClr val="C9D2DD"/>
+              <a:srgbClr val="5B6B82"/>
             </a:solidFill>
           </a:ln>
         </p:spPr>
@@ -3276,7 +3276,7 @@
           </a:solidFill>
           <a:ln xmlns:a="http://schemas.openxmlformats.org/drawingml/2006/main">
             <a:solidFill>
-              <a:srgbClr val="C9D2DD"/>
+              <a:srgbClr val="5B6B82"/>
             </a:solidFill>
           </a:ln>
         </p:spPr>
@@ -3521,7 +3521,7 @@
           </a:solidFill>
           <a:ln xmlns:a="http://schemas.openxmlformats.org/drawingml/2006/main">
             <a:solidFill>
-              <a:srgbClr val="C9D2DD"/>
+              <a:srgbClr val="5B6B82"/>
             </a:solidFill>
           </a:ln>
         </p:spPr>

</xml_diff>